<commit_message>
updated readme to explain architecture + added architecture diagram
</commit_message>
<xml_diff>
--- a/privateAI-demo-architecture_v1.0.pptx
+++ b/privateAI-demo-architecture_v1.0.pptx
@@ -3384,62 +3384,12 @@
           </a:p>
         </p:txBody>
       </p:sp>
-      <p:sp>
-        <p:nvSpPr>
-          <p:cNvPr id="32" name="Round Diagonal Corner of Rectangle 31">
-            <a:extLst>
-              <a:ext uri="{FF2B5EF4-FFF2-40B4-BE49-F238E27FC236}">
-                <a16:creationId xmlns:a16="http://schemas.microsoft.com/office/drawing/2014/main" id="{DFF77CE2-8053-911D-0276-3C4A921D4849}"/>
-              </a:ext>
-            </a:extLst>
-          </p:cNvPr>
-          <p:cNvSpPr/>
-          <p:nvPr/>
-        </p:nvSpPr>
-        <p:spPr>
-          <a:xfrm>
-            <a:off x="215153" y="348792"/>
-            <a:ext cx="7546361" cy="1791093"/>
-          </a:xfrm>
-          <a:prstGeom prst="round2DiagRect">
-            <a:avLst/>
-          </a:prstGeom>
-          <a:solidFill>
-            <a:schemeClr val="tx2">
-              <a:lumMod val="10000"/>
-              <a:lumOff val="90000"/>
-            </a:schemeClr>
-          </a:solidFill>
-        </p:spPr>
-        <p:style>
-          <a:lnRef idx="2">
-            <a:schemeClr val="accent4"/>
-          </a:lnRef>
-          <a:fillRef idx="1">
-            <a:schemeClr val="lt1"/>
-          </a:fillRef>
-          <a:effectRef idx="0">
-            <a:schemeClr val="accent4"/>
-          </a:effectRef>
-          <a:fontRef idx="minor">
-            <a:schemeClr val="dk1"/>
-          </a:fontRef>
-        </p:style>
-        <p:txBody>
-          <a:bodyPr rtlCol="0" anchor="ctr"/>
-          <a:lstStyle/>
-          <a:p>
-            <a:pPr algn="ctr"/>
-            <a:endParaRPr lang="en-GB"/>
-          </a:p>
-        </p:txBody>
-      </p:sp>
       <p:grpSp>
         <p:nvGrpSpPr>
-          <p:cNvPr id="7" name="Group 6">
-            <a:extLst>
-              <a:ext uri="{FF2B5EF4-FFF2-40B4-BE49-F238E27FC236}">
-                <a16:creationId xmlns:a16="http://schemas.microsoft.com/office/drawing/2014/main" id="{97AFD346-20E6-7EBE-49EF-05BDEF108250}"/>
+          <p:cNvPr id="2" name="Group 1">
+            <a:extLst>
+              <a:ext uri="{FF2B5EF4-FFF2-40B4-BE49-F238E27FC236}">
+                <a16:creationId xmlns:a16="http://schemas.microsoft.com/office/drawing/2014/main" id="{21C6D687-6974-550D-D335-FAF5BFD76055}"/>
               </a:ext>
             </a:extLst>
           </p:cNvPr>
@@ -3448,18 +3398,18 @@
         </p:nvGrpSpPr>
         <p:grpSpPr>
           <a:xfrm>
-            <a:off x="2903547" y="676606"/>
-            <a:ext cx="1658471" cy="1219199"/>
-            <a:chOff x="3290046" y="1138519"/>
-            <a:chExt cx="1658471" cy="1219199"/>
+            <a:off x="215153" y="348792"/>
+            <a:ext cx="7546361" cy="1791093"/>
+            <a:chOff x="215153" y="348792"/>
+            <a:chExt cx="7546361" cy="1791093"/>
           </a:xfrm>
         </p:grpSpPr>
         <p:sp>
           <p:nvSpPr>
-            <p:cNvPr id="4" name="Rounded Rectangle 3">
+            <p:cNvPr id="32" name="Round Diagonal Corner of Rectangle 31">
               <a:extLst>
                 <a:ext uri="{FF2B5EF4-FFF2-40B4-BE49-F238E27FC236}">
-                  <a16:creationId xmlns:a16="http://schemas.microsoft.com/office/drawing/2014/main" id="{4A3EEA08-1C7B-BBAB-7865-8B2904B2B4F5}"/>
+                  <a16:creationId xmlns:a16="http://schemas.microsoft.com/office/drawing/2014/main" id="{DFF77CE2-8053-911D-0276-3C4A921D4849}"/>
                 </a:ext>
               </a:extLst>
             </p:cNvPr>
@@ -3468,8 +3418,194 @@
           </p:nvSpPr>
           <p:spPr>
             <a:xfrm>
-              <a:off x="3290046" y="1138519"/>
+              <a:off x="215153" y="348792"/>
+              <a:ext cx="7546361" cy="1791093"/>
+            </a:xfrm>
+            <a:prstGeom prst="round2DiagRect">
+              <a:avLst/>
+            </a:prstGeom>
+            <a:solidFill>
+              <a:schemeClr val="tx2">
+                <a:lumMod val="10000"/>
+                <a:lumOff val="90000"/>
+              </a:schemeClr>
+            </a:solidFill>
+          </p:spPr>
+          <p:style>
+            <a:lnRef idx="2">
+              <a:schemeClr val="accent4"/>
+            </a:lnRef>
+            <a:fillRef idx="1">
+              <a:schemeClr val="lt1"/>
+            </a:fillRef>
+            <a:effectRef idx="0">
+              <a:schemeClr val="accent4"/>
+            </a:effectRef>
+            <a:fontRef idx="minor">
+              <a:schemeClr val="dk1"/>
+            </a:fontRef>
+          </p:style>
+          <p:txBody>
+            <a:bodyPr rtlCol="0" anchor="ctr"/>
+            <a:lstStyle/>
+            <a:p>
+              <a:pPr algn="ctr"/>
+              <a:endParaRPr lang="en-GB"/>
+            </a:p>
+          </p:txBody>
+        </p:sp>
+        <p:grpSp>
+          <p:nvGrpSpPr>
+            <p:cNvPr id="7" name="Group 6">
+              <a:extLst>
+                <a:ext uri="{FF2B5EF4-FFF2-40B4-BE49-F238E27FC236}">
+                  <a16:creationId xmlns:a16="http://schemas.microsoft.com/office/drawing/2014/main" id="{97AFD346-20E6-7EBE-49EF-05BDEF108250}"/>
+                </a:ext>
+              </a:extLst>
+            </p:cNvPr>
+            <p:cNvGrpSpPr/>
+            <p:nvPr/>
+          </p:nvGrpSpPr>
+          <p:grpSpPr>
+            <a:xfrm>
+              <a:off x="2903547" y="676606"/>
               <a:ext cx="1658471" cy="1219199"/>
+              <a:chOff x="3290046" y="1138519"/>
+              <a:chExt cx="1658471" cy="1219199"/>
+            </a:xfrm>
+          </p:grpSpPr>
+          <p:sp>
+            <p:nvSpPr>
+              <p:cNvPr id="4" name="Rounded Rectangle 3">
+                <a:extLst>
+                  <a:ext uri="{FF2B5EF4-FFF2-40B4-BE49-F238E27FC236}">
+                    <a16:creationId xmlns:a16="http://schemas.microsoft.com/office/drawing/2014/main" id="{4A3EEA08-1C7B-BBAB-7865-8B2904B2B4F5}"/>
+                  </a:ext>
+                </a:extLst>
+              </p:cNvPr>
+              <p:cNvSpPr/>
+              <p:nvPr/>
+            </p:nvSpPr>
+            <p:spPr>
+              <a:xfrm>
+                <a:off x="3290046" y="1138519"/>
+                <a:ext cx="1658471" cy="1219199"/>
+              </a:xfrm>
+              <a:prstGeom prst="roundRect">
+                <a:avLst>
+                  <a:gd name="adj" fmla="val 7113"/>
+                </a:avLst>
+              </a:prstGeom>
+            </p:spPr>
+            <p:style>
+              <a:lnRef idx="2">
+                <a:schemeClr val="accent1">
+                  <a:shade val="15000"/>
+                </a:schemeClr>
+              </a:lnRef>
+              <a:fillRef idx="1">
+                <a:schemeClr val="accent1"/>
+              </a:fillRef>
+              <a:effectRef idx="0">
+                <a:schemeClr val="accent1"/>
+              </a:effectRef>
+              <a:fontRef idx="minor">
+                <a:schemeClr val="lt1"/>
+              </a:fontRef>
+            </p:style>
+            <p:txBody>
+              <a:bodyPr rtlCol="0" anchor="t"/>
+              <a:lstStyle/>
+              <a:p>
+                <a:pPr algn="ctr"/>
+                <a:r>
+                  <a:rPr lang="en-GB" sz="1400" dirty="0"/>
+                  <a:t>Ingest Script</a:t>
+                </a:r>
+                <a:br>
+                  <a:rPr lang="en-GB" sz="1400" dirty="0"/>
+                </a:br>
+                <a:r>
+                  <a:rPr lang="en-GB" sz="1400" dirty="0"/>
+                  <a:t>(ingestData.py)</a:t>
+                </a:r>
+              </a:p>
+            </p:txBody>
+          </p:sp>
+          <p:sp>
+            <p:nvSpPr>
+              <p:cNvPr id="6" name="Rounded Rectangle 5">
+                <a:extLst>
+                  <a:ext uri="{FF2B5EF4-FFF2-40B4-BE49-F238E27FC236}">
+                    <a16:creationId xmlns:a16="http://schemas.microsoft.com/office/drawing/2014/main" id="{D3C601C6-F132-4071-3F5B-E6DB25C4B7AA}"/>
+                  </a:ext>
+                </a:extLst>
+              </p:cNvPr>
+              <p:cNvSpPr/>
+              <p:nvPr/>
+            </p:nvSpPr>
+            <p:spPr>
+              <a:xfrm>
+                <a:off x="3426757" y="1748118"/>
+                <a:ext cx="1385048" cy="537882"/>
+              </a:xfrm>
+              <a:prstGeom prst="roundRect">
+                <a:avLst/>
+              </a:prstGeom>
+              <a:ln>
+                <a:solidFill>
+                  <a:schemeClr val="tx2">
+                    <a:lumMod val="25000"/>
+                    <a:lumOff val="75000"/>
+                  </a:schemeClr>
+                </a:solidFill>
+              </a:ln>
+            </p:spPr>
+            <p:style>
+              <a:lnRef idx="2">
+                <a:schemeClr val="accent4">
+                  <a:shade val="15000"/>
+                </a:schemeClr>
+              </a:lnRef>
+              <a:fillRef idx="1">
+                <a:schemeClr val="accent4"/>
+              </a:fillRef>
+              <a:effectRef idx="0">
+                <a:schemeClr val="accent4"/>
+              </a:effectRef>
+              <a:fontRef idx="minor">
+                <a:schemeClr val="lt1"/>
+              </a:fontRef>
+            </p:style>
+            <p:txBody>
+              <a:bodyPr rtlCol="0" anchor="ctr"/>
+              <a:lstStyle/>
+              <a:p>
+                <a:pPr algn="ctr"/>
+                <a:r>
+                  <a:rPr lang="en-GB" sz="1400" dirty="0"/>
+                  <a:t>Text Extraction &amp; Chunking</a:t>
+                </a:r>
+              </a:p>
+            </p:txBody>
+          </p:sp>
+        </p:grpSp>
+        <p:sp>
+          <p:nvSpPr>
+            <p:cNvPr id="8" name="Rounded Rectangle 7">
+              <a:extLst>
+                <a:ext uri="{FF2B5EF4-FFF2-40B4-BE49-F238E27FC236}">
+                  <a16:creationId xmlns:a16="http://schemas.microsoft.com/office/drawing/2014/main" id="{4EBD33BC-EB85-E17A-CF9E-C4DE15CB682D}"/>
+                </a:ext>
+              </a:extLst>
+            </p:cNvPr>
+            <p:cNvSpPr/>
+            <p:nvPr/>
+          </p:nvSpPr>
+          <p:spPr>
+            <a:xfrm>
+              <a:off x="5848453" y="851416"/>
+              <a:ext cx="1658471" cy="779930"/>
             </a:xfrm>
             <a:prstGeom prst="roundRect">
               <a:avLst>
@@ -3494,30 +3630,354 @@
             </a:fontRef>
           </p:style>
           <p:txBody>
-            <a:bodyPr rtlCol="0" anchor="t"/>
+            <a:bodyPr rtlCol="0" anchor="ctr"/>
             <a:lstStyle/>
             <a:p>
               <a:pPr algn="ctr"/>
               <a:r>
                 <a:rPr lang="en-GB" sz="1400" dirty="0"/>
-                <a:t>Ingest Script</a:t>
+                <a:t>Ollama</a:t>
               </a:r>
               <a:br>
                 <a:rPr lang="en-GB" sz="1400" dirty="0"/>
               </a:br>
               <a:r>
                 <a:rPr lang="en-GB" sz="1400" dirty="0"/>
-                <a:t>(ingestData.py)</a:t>
+                <a:t>embedding model</a:t>
+              </a:r>
+              <a:br>
+                <a:rPr lang="en-GB" sz="1400" dirty="0"/>
+              </a:br>
+              <a:r>
+                <a:rPr lang="en-GB" sz="1400" dirty="0"/>
+                <a:t>bge-m3</a:t>
               </a:r>
             </a:p>
           </p:txBody>
         </p:sp>
+        <p:grpSp>
+          <p:nvGrpSpPr>
+            <p:cNvPr id="12" name="Group 11">
+              <a:extLst>
+                <a:ext uri="{FF2B5EF4-FFF2-40B4-BE49-F238E27FC236}">
+                  <a16:creationId xmlns:a16="http://schemas.microsoft.com/office/drawing/2014/main" id="{70936E44-77EC-F875-29AD-9539AAAF9AF1}"/>
+                </a:ext>
+              </a:extLst>
+            </p:cNvPr>
+            <p:cNvGrpSpPr/>
+            <p:nvPr/>
+          </p:nvGrpSpPr>
+          <p:grpSpPr>
+            <a:xfrm>
+              <a:off x="4761483" y="1026414"/>
+              <a:ext cx="887506" cy="519581"/>
+              <a:chOff x="5221941" y="1443503"/>
+              <a:chExt cx="887506" cy="519581"/>
+            </a:xfrm>
+          </p:grpSpPr>
+          <p:sp>
+            <p:nvSpPr>
+              <p:cNvPr id="9" name="Right Arrow 8">
+                <a:extLst>
+                  <a:ext uri="{FF2B5EF4-FFF2-40B4-BE49-F238E27FC236}">
+                    <a16:creationId xmlns:a16="http://schemas.microsoft.com/office/drawing/2014/main" id="{7ADB76E2-BDD1-3A63-E5C6-8C20240294CA}"/>
+                  </a:ext>
+                </a:extLst>
+              </p:cNvPr>
+              <p:cNvSpPr/>
+              <p:nvPr/>
+            </p:nvSpPr>
+            <p:spPr>
+              <a:xfrm>
+                <a:off x="5221941" y="1443503"/>
+                <a:ext cx="887506" cy="214968"/>
+              </a:xfrm>
+              <a:prstGeom prst="rightArrow">
+                <a:avLst/>
+              </a:prstGeom>
+            </p:spPr>
+            <p:style>
+              <a:lnRef idx="2">
+                <a:schemeClr val="accent4">
+                  <a:shade val="15000"/>
+                </a:schemeClr>
+              </a:lnRef>
+              <a:fillRef idx="1">
+                <a:schemeClr val="accent4"/>
+              </a:fillRef>
+              <a:effectRef idx="0">
+                <a:schemeClr val="accent4"/>
+              </a:effectRef>
+              <a:fontRef idx="minor">
+                <a:schemeClr val="lt1"/>
+              </a:fontRef>
+            </p:style>
+            <p:txBody>
+              <a:bodyPr rtlCol="0" anchor="ctr"/>
+              <a:lstStyle/>
+              <a:p>
+                <a:pPr algn="ctr"/>
+                <a:endParaRPr lang="en-GB"/>
+              </a:p>
+            </p:txBody>
+          </p:sp>
+          <p:sp>
+            <p:nvSpPr>
+              <p:cNvPr id="11" name="Right Arrow 10">
+                <a:extLst>
+                  <a:ext uri="{FF2B5EF4-FFF2-40B4-BE49-F238E27FC236}">
+                    <a16:creationId xmlns:a16="http://schemas.microsoft.com/office/drawing/2014/main" id="{E46EECB8-85F7-613E-CED4-B1EF8B43B57B}"/>
+                  </a:ext>
+                </a:extLst>
+              </p:cNvPr>
+              <p:cNvSpPr/>
+              <p:nvPr/>
+            </p:nvSpPr>
+            <p:spPr>
+              <a:xfrm rot="10800000">
+                <a:off x="5221941" y="1748117"/>
+                <a:ext cx="887506" cy="214967"/>
+              </a:xfrm>
+              <a:prstGeom prst="rightArrow">
+                <a:avLst/>
+              </a:prstGeom>
+            </p:spPr>
+            <p:style>
+              <a:lnRef idx="2">
+                <a:schemeClr val="accent4">
+                  <a:shade val="15000"/>
+                </a:schemeClr>
+              </a:lnRef>
+              <a:fillRef idx="1">
+                <a:schemeClr val="accent4"/>
+              </a:fillRef>
+              <a:effectRef idx="0">
+                <a:schemeClr val="accent4"/>
+              </a:effectRef>
+              <a:fontRef idx="minor">
+                <a:schemeClr val="lt1"/>
+              </a:fontRef>
+            </p:style>
+            <p:txBody>
+              <a:bodyPr rtlCol="0" anchor="ctr"/>
+              <a:lstStyle/>
+              <a:p>
+                <a:pPr algn="ctr"/>
+                <a:endParaRPr lang="en-GB"/>
+              </a:p>
+            </p:txBody>
+          </p:sp>
+        </p:grpSp>
+        <p:grpSp>
+          <p:nvGrpSpPr>
+            <p:cNvPr id="38" name="Group 37">
+              <a:extLst>
+                <a:ext uri="{FF2B5EF4-FFF2-40B4-BE49-F238E27FC236}">
+                  <a16:creationId xmlns:a16="http://schemas.microsoft.com/office/drawing/2014/main" id="{3409DBE2-FD9D-FB75-32F1-69EF26E4010D}"/>
+                </a:ext>
+              </a:extLst>
+            </p:cNvPr>
+            <p:cNvGrpSpPr/>
+            <p:nvPr/>
+          </p:nvGrpSpPr>
+          <p:grpSpPr>
+            <a:xfrm>
+              <a:off x="462115" y="775488"/>
+              <a:ext cx="1399718" cy="1326046"/>
+              <a:chOff x="4249271" y="3922912"/>
+              <a:chExt cx="1399718" cy="1326046"/>
+            </a:xfrm>
+          </p:grpSpPr>
+          <p:sp>
+            <p:nvSpPr>
+              <p:cNvPr id="37" name="Rounded Rectangle 36">
+                <a:extLst>
+                  <a:ext uri="{FF2B5EF4-FFF2-40B4-BE49-F238E27FC236}">
+                    <a16:creationId xmlns:a16="http://schemas.microsoft.com/office/drawing/2014/main" id="{9932AB39-7864-A6FA-C7A1-714275EA0685}"/>
+                  </a:ext>
+                </a:extLst>
+              </p:cNvPr>
+              <p:cNvSpPr/>
+              <p:nvPr/>
+            </p:nvSpPr>
+            <p:spPr>
+              <a:xfrm>
+                <a:off x="4249271" y="3922912"/>
+                <a:ext cx="1399718" cy="774387"/>
+              </a:xfrm>
+              <a:prstGeom prst="roundRect">
+                <a:avLst>
+                  <a:gd name="adj" fmla="val 15509"/>
+                </a:avLst>
+              </a:prstGeom>
+              <a:solidFill>
+                <a:schemeClr val="bg1"/>
+              </a:solidFill>
+              <a:ln>
+                <a:solidFill>
+                  <a:schemeClr val="tx2">
+                    <a:lumMod val="75000"/>
+                    <a:lumOff val="25000"/>
+                  </a:schemeClr>
+                </a:solidFill>
+              </a:ln>
+            </p:spPr>
+            <p:style>
+              <a:lnRef idx="2">
+                <a:schemeClr val="accent1">
+                  <a:shade val="15000"/>
+                </a:schemeClr>
+              </a:lnRef>
+              <a:fillRef idx="1">
+                <a:schemeClr val="accent1"/>
+              </a:fillRef>
+              <a:effectRef idx="0">
+                <a:schemeClr val="accent1"/>
+              </a:effectRef>
+              <a:fontRef idx="minor">
+                <a:schemeClr val="lt1"/>
+              </a:fontRef>
+            </p:style>
+            <p:txBody>
+              <a:bodyPr rtlCol="0" anchor="ctr"/>
+              <a:lstStyle/>
+              <a:p>
+                <a:pPr algn="ctr"/>
+                <a:endParaRPr lang="en-GB"/>
+              </a:p>
+            </p:txBody>
+          </p:sp>
+          <p:grpSp>
+            <p:nvGrpSpPr>
+              <p:cNvPr id="20" name="Group 19">
+                <a:extLst>
+                  <a:ext uri="{FF2B5EF4-FFF2-40B4-BE49-F238E27FC236}">
+                    <a16:creationId xmlns:a16="http://schemas.microsoft.com/office/drawing/2014/main" id="{D0DDD279-727E-10B8-408C-FF339A5AD69B}"/>
+                  </a:ext>
+                </a:extLst>
+              </p:cNvPr>
+              <p:cNvGrpSpPr/>
+              <p:nvPr/>
+            </p:nvGrpSpPr>
+            <p:grpSpPr>
+              <a:xfrm>
+                <a:off x="4356002" y="4045391"/>
+                <a:ext cx="1133182" cy="1203567"/>
+                <a:chOff x="1437018" y="1203883"/>
+                <a:chExt cx="1133182" cy="1203567"/>
+              </a:xfrm>
+            </p:grpSpPr>
+            <p:pic>
+              <p:nvPicPr>
+                <p:cNvPr id="17" name="Picture 16" descr="Pdf - Free files and folders icons">
+                  <a:extLst>
+                    <a:ext uri="{FF2B5EF4-FFF2-40B4-BE49-F238E27FC236}">
+                      <a16:creationId xmlns:a16="http://schemas.microsoft.com/office/drawing/2014/main" id="{B055A659-AE7E-B6B5-EDD6-A79988AFD3C2}"/>
+                    </a:ext>
+                  </a:extLst>
+                </p:cNvPr>
+                <p:cNvPicPr>
+                  <a:picLocks noChangeAspect="1"/>
+                </p:cNvPicPr>
+                <p:nvPr/>
+              </p:nvPicPr>
+              <p:blipFill>
+                <a:blip r:embed="rId2"/>
+                <a:stretch>
+                  <a:fillRect/>
+                </a:stretch>
+              </p:blipFill>
+              <p:spPr>
+                <a:xfrm>
+                  <a:off x="1506322" y="1203883"/>
+                  <a:ext cx="497287" cy="497287"/>
+                </a:xfrm>
+                <a:prstGeom prst="rect">
+                  <a:avLst/>
+                </a:prstGeom>
+              </p:spPr>
+            </p:pic>
+            <p:pic>
+              <p:nvPicPr>
+                <p:cNvPr id="18" name="Picture 17" descr="Pdf - Free files and folders icons">
+                  <a:extLst>
+                    <a:ext uri="{FF2B5EF4-FFF2-40B4-BE49-F238E27FC236}">
+                      <a16:creationId xmlns:a16="http://schemas.microsoft.com/office/drawing/2014/main" id="{F6606924-0A96-3677-9A6C-CD5B996019A3}"/>
+                    </a:ext>
+                  </a:extLst>
+                </p:cNvPr>
+                <p:cNvPicPr>
+                  <a:picLocks noChangeAspect="1"/>
+                </p:cNvPicPr>
+                <p:nvPr/>
+              </p:nvPicPr>
+              <p:blipFill>
+                <a:blip r:embed="rId2"/>
+                <a:stretch>
+                  <a:fillRect/>
+                </a:stretch>
+              </p:blipFill>
+              <p:spPr>
+                <a:xfrm>
+                  <a:off x="2072912" y="1203883"/>
+                  <a:ext cx="497287" cy="497287"/>
+                </a:xfrm>
+                <a:prstGeom prst="rect">
+                  <a:avLst/>
+                </a:prstGeom>
+              </p:spPr>
+            </p:pic>
+            <p:sp>
+              <p:nvSpPr>
+                <p:cNvPr id="19" name="TextBox 18">
+                  <a:extLst>
+                    <a:ext uri="{FF2B5EF4-FFF2-40B4-BE49-F238E27FC236}">
+                      <a16:creationId xmlns:a16="http://schemas.microsoft.com/office/drawing/2014/main" id="{90A79CEC-205D-04EC-1E02-C401BA17D71F}"/>
+                    </a:ext>
+                  </a:extLst>
+                </p:cNvPr>
+                <p:cNvSpPr txBox="1"/>
+                <p:nvPr/>
+              </p:nvSpPr>
+              <p:spPr>
+                <a:xfrm>
+                  <a:off x="1437018" y="1884230"/>
+                  <a:ext cx="1133182" cy="523220"/>
+                </a:xfrm>
+                <a:prstGeom prst="rect">
+                  <a:avLst/>
+                </a:prstGeom>
+                <a:noFill/>
+              </p:spPr>
+              <p:txBody>
+                <a:bodyPr wrap="square" rtlCol="0">
+                  <a:spAutoFit/>
+                </a:bodyPr>
+                <a:lstStyle/>
+                <a:p>
+                  <a:pPr algn="ctr"/>
+                  <a:r>
+                    <a:rPr lang="en-GB" sz="1400" dirty="0"/>
+                    <a:t>Local VCF </a:t>
+                  </a:r>
+                  <a:br>
+                    <a:rPr lang="en-GB" sz="1400" dirty="0"/>
+                  </a:br>
+                  <a:r>
+                    <a:rPr lang="en-GB" sz="1400" dirty="0"/>
+                    <a:t>documents</a:t>
+                  </a:r>
+                </a:p>
+              </p:txBody>
+            </p:sp>
+          </p:grpSp>
+        </p:grpSp>
         <p:sp>
           <p:nvSpPr>
-            <p:cNvPr id="6" name="Rounded Rectangle 5">
+            <p:cNvPr id="22" name="Right Arrow 21">
               <a:extLst>
                 <a:ext uri="{FF2B5EF4-FFF2-40B4-BE49-F238E27FC236}">
-                  <a16:creationId xmlns:a16="http://schemas.microsoft.com/office/drawing/2014/main" id="{D3C601C6-F132-4071-3F5B-E6DB25C4B7AA}"/>
+                  <a16:creationId xmlns:a16="http://schemas.microsoft.com/office/drawing/2014/main" id="{B3BF4949-14B9-60B0-743D-F63A83E45C3A}"/>
                 </a:ext>
               </a:extLst>
             </p:cNvPr>
@@ -3526,150 +3986,7 @@
           </p:nvSpPr>
           <p:spPr>
             <a:xfrm>
-              <a:off x="3426757" y="1748118"/>
-              <a:ext cx="1385048" cy="537882"/>
-            </a:xfrm>
-            <a:prstGeom prst="roundRect">
-              <a:avLst/>
-            </a:prstGeom>
-            <a:ln>
-              <a:solidFill>
-                <a:schemeClr val="tx2">
-                  <a:lumMod val="25000"/>
-                  <a:lumOff val="75000"/>
-                </a:schemeClr>
-              </a:solidFill>
-            </a:ln>
-          </p:spPr>
-          <p:style>
-            <a:lnRef idx="2">
-              <a:schemeClr val="accent4">
-                <a:shade val="15000"/>
-              </a:schemeClr>
-            </a:lnRef>
-            <a:fillRef idx="1">
-              <a:schemeClr val="accent4"/>
-            </a:fillRef>
-            <a:effectRef idx="0">
-              <a:schemeClr val="accent4"/>
-            </a:effectRef>
-            <a:fontRef idx="minor">
-              <a:schemeClr val="lt1"/>
-            </a:fontRef>
-          </p:style>
-          <p:txBody>
-            <a:bodyPr rtlCol="0" anchor="ctr"/>
-            <a:lstStyle/>
-            <a:p>
-              <a:pPr algn="ctr"/>
-              <a:r>
-                <a:rPr lang="en-GB" sz="1400" dirty="0"/>
-                <a:t>Text Extraction &amp; Chunking</a:t>
-              </a:r>
-            </a:p>
-          </p:txBody>
-        </p:sp>
-      </p:grpSp>
-      <p:sp>
-        <p:nvSpPr>
-          <p:cNvPr id="8" name="Rounded Rectangle 7">
-            <a:extLst>
-              <a:ext uri="{FF2B5EF4-FFF2-40B4-BE49-F238E27FC236}">
-                <a16:creationId xmlns:a16="http://schemas.microsoft.com/office/drawing/2014/main" id="{4EBD33BC-EB85-E17A-CF9E-C4DE15CB682D}"/>
-              </a:ext>
-            </a:extLst>
-          </p:cNvPr>
-          <p:cNvSpPr/>
-          <p:nvPr/>
-        </p:nvSpPr>
-        <p:spPr>
-          <a:xfrm>
-            <a:off x="5848453" y="851416"/>
-            <a:ext cx="1658471" cy="779930"/>
-          </a:xfrm>
-          <a:prstGeom prst="roundRect">
-            <a:avLst>
-              <a:gd name="adj" fmla="val 7113"/>
-            </a:avLst>
-          </a:prstGeom>
-        </p:spPr>
-        <p:style>
-          <a:lnRef idx="2">
-            <a:schemeClr val="accent1">
-              <a:shade val="15000"/>
-            </a:schemeClr>
-          </a:lnRef>
-          <a:fillRef idx="1">
-            <a:schemeClr val="accent1"/>
-          </a:fillRef>
-          <a:effectRef idx="0">
-            <a:schemeClr val="accent1"/>
-          </a:effectRef>
-          <a:fontRef idx="minor">
-            <a:schemeClr val="lt1"/>
-          </a:fontRef>
-        </p:style>
-        <p:txBody>
-          <a:bodyPr rtlCol="0" anchor="ctr"/>
-          <a:lstStyle/>
-          <a:p>
-            <a:pPr algn="ctr"/>
-            <a:r>
-              <a:rPr lang="en-GB" sz="1400" dirty="0"/>
-              <a:t>Ollama</a:t>
-            </a:r>
-            <a:br>
-              <a:rPr lang="en-GB" sz="1400" dirty="0"/>
-            </a:br>
-            <a:r>
-              <a:rPr lang="en-GB" sz="1400" dirty="0"/>
-              <a:t>embedding model</a:t>
-            </a:r>
-            <a:br>
-              <a:rPr lang="en-GB" sz="1400" dirty="0"/>
-            </a:br>
-            <a:r>
-              <a:rPr lang="en-GB" sz="1400" dirty="0"/>
-              <a:t>bge-m3</a:t>
-            </a:r>
-          </a:p>
-        </p:txBody>
-      </p:sp>
-      <p:grpSp>
-        <p:nvGrpSpPr>
-          <p:cNvPr id="12" name="Group 11">
-            <a:extLst>
-              <a:ext uri="{FF2B5EF4-FFF2-40B4-BE49-F238E27FC236}">
-                <a16:creationId xmlns:a16="http://schemas.microsoft.com/office/drawing/2014/main" id="{70936E44-77EC-F875-29AD-9539AAAF9AF1}"/>
-              </a:ext>
-            </a:extLst>
-          </p:cNvPr>
-          <p:cNvGrpSpPr/>
-          <p:nvPr/>
-        </p:nvGrpSpPr>
-        <p:grpSpPr>
-          <a:xfrm>
-            <a:off x="4761483" y="1026414"/>
-            <a:ext cx="887506" cy="519581"/>
-            <a:chOff x="5221941" y="1443503"/>
-            <a:chExt cx="887506" cy="519581"/>
-          </a:xfrm>
-        </p:grpSpPr>
-        <p:sp>
-          <p:nvSpPr>
-            <p:cNvPr id="9" name="Right Arrow 8">
-              <a:extLst>
-                <a:ext uri="{FF2B5EF4-FFF2-40B4-BE49-F238E27FC236}">
-                  <a16:creationId xmlns:a16="http://schemas.microsoft.com/office/drawing/2014/main" id="{7ADB76E2-BDD1-3A63-E5C6-8C20240294CA}"/>
-                </a:ext>
-              </a:extLst>
-            </p:cNvPr>
-            <p:cNvSpPr/>
-            <p:nvPr/>
-          </p:nvSpPr>
-          <p:spPr>
-            <a:xfrm>
-              <a:off x="5221941" y="1443503"/>
+              <a:off x="1930188" y="1178721"/>
               <a:ext cx="887506" cy="214968"/>
             </a:xfrm>
             <a:prstGeom prst="rightArrow">
@@ -3701,303 +4018,7 @@
             </a:p>
           </p:txBody>
         </p:sp>
-        <p:sp>
-          <p:nvSpPr>
-            <p:cNvPr id="11" name="Right Arrow 10">
-              <a:extLst>
-                <a:ext uri="{FF2B5EF4-FFF2-40B4-BE49-F238E27FC236}">
-                  <a16:creationId xmlns:a16="http://schemas.microsoft.com/office/drawing/2014/main" id="{E46EECB8-85F7-613E-CED4-B1EF8B43B57B}"/>
-                </a:ext>
-              </a:extLst>
-            </p:cNvPr>
-            <p:cNvSpPr/>
-            <p:nvPr/>
-          </p:nvSpPr>
-          <p:spPr>
-            <a:xfrm rot="10800000">
-              <a:off x="5221941" y="1748117"/>
-              <a:ext cx="887506" cy="214967"/>
-            </a:xfrm>
-            <a:prstGeom prst="rightArrow">
-              <a:avLst/>
-            </a:prstGeom>
-          </p:spPr>
-          <p:style>
-            <a:lnRef idx="2">
-              <a:schemeClr val="accent4">
-                <a:shade val="15000"/>
-              </a:schemeClr>
-            </a:lnRef>
-            <a:fillRef idx="1">
-              <a:schemeClr val="accent4"/>
-            </a:fillRef>
-            <a:effectRef idx="0">
-              <a:schemeClr val="accent4"/>
-            </a:effectRef>
-            <a:fontRef idx="minor">
-              <a:schemeClr val="lt1"/>
-            </a:fontRef>
-          </p:style>
-          <p:txBody>
-            <a:bodyPr rtlCol="0" anchor="ctr"/>
-            <a:lstStyle/>
-            <a:p>
-              <a:pPr algn="ctr"/>
-              <a:endParaRPr lang="en-GB"/>
-            </a:p>
-          </p:txBody>
-        </p:sp>
       </p:grpSp>
-      <p:grpSp>
-        <p:nvGrpSpPr>
-          <p:cNvPr id="38" name="Group 37">
-            <a:extLst>
-              <a:ext uri="{FF2B5EF4-FFF2-40B4-BE49-F238E27FC236}">
-                <a16:creationId xmlns:a16="http://schemas.microsoft.com/office/drawing/2014/main" id="{3409DBE2-FD9D-FB75-32F1-69EF26E4010D}"/>
-              </a:ext>
-            </a:extLst>
-          </p:cNvPr>
-          <p:cNvGrpSpPr/>
-          <p:nvPr/>
-        </p:nvGrpSpPr>
-        <p:grpSpPr>
-          <a:xfrm>
-            <a:off x="462115" y="775488"/>
-            <a:ext cx="1399718" cy="1326046"/>
-            <a:chOff x="4249271" y="3922912"/>
-            <a:chExt cx="1399718" cy="1326046"/>
-          </a:xfrm>
-        </p:grpSpPr>
-        <p:sp>
-          <p:nvSpPr>
-            <p:cNvPr id="37" name="Rounded Rectangle 36">
-              <a:extLst>
-                <a:ext uri="{FF2B5EF4-FFF2-40B4-BE49-F238E27FC236}">
-                  <a16:creationId xmlns:a16="http://schemas.microsoft.com/office/drawing/2014/main" id="{9932AB39-7864-A6FA-C7A1-714275EA0685}"/>
-                </a:ext>
-              </a:extLst>
-            </p:cNvPr>
-            <p:cNvSpPr/>
-            <p:nvPr/>
-          </p:nvSpPr>
-          <p:spPr>
-            <a:xfrm>
-              <a:off x="4249271" y="3922912"/>
-              <a:ext cx="1399718" cy="774387"/>
-            </a:xfrm>
-            <a:prstGeom prst="roundRect">
-              <a:avLst>
-                <a:gd name="adj" fmla="val 15509"/>
-              </a:avLst>
-            </a:prstGeom>
-            <a:solidFill>
-              <a:schemeClr val="bg1"/>
-            </a:solidFill>
-            <a:ln>
-              <a:solidFill>
-                <a:schemeClr val="tx2">
-                  <a:lumMod val="75000"/>
-                  <a:lumOff val="25000"/>
-                </a:schemeClr>
-              </a:solidFill>
-            </a:ln>
-          </p:spPr>
-          <p:style>
-            <a:lnRef idx="2">
-              <a:schemeClr val="accent1">
-                <a:shade val="15000"/>
-              </a:schemeClr>
-            </a:lnRef>
-            <a:fillRef idx="1">
-              <a:schemeClr val="accent1"/>
-            </a:fillRef>
-            <a:effectRef idx="0">
-              <a:schemeClr val="accent1"/>
-            </a:effectRef>
-            <a:fontRef idx="minor">
-              <a:schemeClr val="lt1"/>
-            </a:fontRef>
-          </p:style>
-          <p:txBody>
-            <a:bodyPr rtlCol="0" anchor="ctr"/>
-            <a:lstStyle/>
-            <a:p>
-              <a:pPr algn="ctr"/>
-              <a:endParaRPr lang="en-GB"/>
-            </a:p>
-          </p:txBody>
-        </p:sp>
-        <p:grpSp>
-          <p:nvGrpSpPr>
-            <p:cNvPr id="20" name="Group 19">
-              <a:extLst>
-                <a:ext uri="{FF2B5EF4-FFF2-40B4-BE49-F238E27FC236}">
-                  <a16:creationId xmlns:a16="http://schemas.microsoft.com/office/drawing/2014/main" id="{D0DDD279-727E-10B8-408C-FF339A5AD69B}"/>
-                </a:ext>
-              </a:extLst>
-            </p:cNvPr>
-            <p:cNvGrpSpPr/>
-            <p:nvPr/>
-          </p:nvGrpSpPr>
-          <p:grpSpPr>
-            <a:xfrm>
-              <a:off x="4356002" y="4045391"/>
-              <a:ext cx="1133182" cy="1203567"/>
-              <a:chOff x="1437018" y="1203883"/>
-              <a:chExt cx="1133182" cy="1203567"/>
-            </a:xfrm>
-          </p:grpSpPr>
-          <p:pic>
-            <p:nvPicPr>
-              <p:cNvPr id="17" name="Picture 16" descr="Pdf - Free files and folders icons">
-                <a:extLst>
-                  <a:ext uri="{FF2B5EF4-FFF2-40B4-BE49-F238E27FC236}">
-                    <a16:creationId xmlns:a16="http://schemas.microsoft.com/office/drawing/2014/main" id="{B055A659-AE7E-B6B5-EDD6-A79988AFD3C2}"/>
-                  </a:ext>
-                </a:extLst>
-              </p:cNvPr>
-              <p:cNvPicPr>
-                <a:picLocks noChangeAspect="1"/>
-              </p:cNvPicPr>
-              <p:nvPr/>
-            </p:nvPicPr>
-            <p:blipFill>
-              <a:blip r:embed="rId2"/>
-              <a:stretch>
-                <a:fillRect/>
-              </a:stretch>
-            </p:blipFill>
-            <p:spPr>
-              <a:xfrm>
-                <a:off x="1506322" y="1203883"/>
-                <a:ext cx="497287" cy="497287"/>
-              </a:xfrm>
-              <a:prstGeom prst="rect">
-                <a:avLst/>
-              </a:prstGeom>
-            </p:spPr>
-          </p:pic>
-          <p:pic>
-            <p:nvPicPr>
-              <p:cNvPr id="18" name="Picture 17" descr="Pdf - Free files and folders icons">
-                <a:extLst>
-                  <a:ext uri="{FF2B5EF4-FFF2-40B4-BE49-F238E27FC236}">
-                    <a16:creationId xmlns:a16="http://schemas.microsoft.com/office/drawing/2014/main" id="{F6606924-0A96-3677-9A6C-CD5B996019A3}"/>
-                  </a:ext>
-                </a:extLst>
-              </p:cNvPr>
-              <p:cNvPicPr>
-                <a:picLocks noChangeAspect="1"/>
-              </p:cNvPicPr>
-              <p:nvPr/>
-            </p:nvPicPr>
-            <p:blipFill>
-              <a:blip r:embed="rId2"/>
-              <a:stretch>
-                <a:fillRect/>
-              </a:stretch>
-            </p:blipFill>
-            <p:spPr>
-              <a:xfrm>
-                <a:off x="2072912" y="1203883"/>
-                <a:ext cx="497287" cy="497287"/>
-              </a:xfrm>
-              <a:prstGeom prst="rect">
-                <a:avLst/>
-              </a:prstGeom>
-            </p:spPr>
-          </p:pic>
-          <p:sp>
-            <p:nvSpPr>
-              <p:cNvPr id="19" name="TextBox 18">
-                <a:extLst>
-                  <a:ext uri="{FF2B5EF4-FFF2-40B4-BE49-F238E27FC236}">
-                    <a16:creationId xmlns:a16="http://schemas.microsoft.com/office/drawing/2014/main" id="{90A79CEC-205D-04EC-1E02-C401BA17D71F}"/>
-                  </a:ext>
-                </a:extLst>
-              </p:cNvPr>
-              <p:cNvSpPr txBox="1"/>
-              <p:nvPr/>
-            </p:nvSpPr>
-            <p:spPr>
-              <a:xfrm>
-                <a:off x="1437018" y="1884230"/>
-                <a:ext cx="1133182" cy="523220"/>
-              </a:xfrm>
-              <a:prstGeom prst="rect">
-                <a:avLst/>
-              </a:prstGeom>
-              <a:noFill/>
-            </p:spPr>
-            <p:txBody>
-              <a:bodyPr wrap="square" rtlCol="0">
-                <a:spAutoFit/>
-              </a:bodyPr>
-              <a:lstStyle/>
-              <a:p>
-                <a:pPr algn="ctr"/>
-                <a:r>
-                  <a:rPr lang="en-GB" sz="1400" dirty="0"/>
-                  <a:t>Local VCF </a:t>
-                </a:r>
-                <a:br>
-                  <a:rPr lang="en-GB" sz="1400" dirty="0"/>
-                </a:br>
-                <a:r>
-                  <a:rPr lang="en-GB" sz="1400" dirty="0"/>
-                  <a:t>documents</a:t>
-                </a:r>
-              </a:p>
-            </p:txBody>
-          </p:sp>
-        </p:grpSp>
-      </p:grpSp>
-      <p:sp>
-        <p:nvSpPr>
-          <p:cNvPr id="22" name="Right Arrow 21">
-            <a:extLst>
-              <a:ext uri="{FF2B5EF4-FFF2-40B4-BE49-F238E27FC236}">
-                <a16:creationId xmlns:a16="http://schemas.microsoft.com/office/drawing/2014/main" id="{B3BF4949-14B9-60B0-743D-F63A83E45C3A}"/>
-              </a:ext>
-            </a:extLst>
-          </p:cNvPr>
-          <p:cNvSpPr/>
-          <p:nvPr/>
-        </p:nvSpPr>
-        <p:spPr>
-          <a:xfrm>
-            <a:off x="1930188" y="1178721"/>
-            <a:ext cx="887506" cy="214968"/>
-          </a:xfrm>
-          <a:prstGeom prst="rightArrow">
-            <a:avLst/>
-          </a:prstGeom>
-        </p:spPr>
-        <p:style>
-          <a:lnRef idx="2">
-            <a:schemeClr val="accent4">
-              <a:shade val="15000"/>
-            </a:schemeClr>
-          </a:lnRef>
-          <a:fillRef idx="1">
-            <a:schemeClr val="accent4"/>
-          </a:fillRef>
-          <a:effectRef idx="0">
-            <a:schemeClr val="accent4"/>
-          </a:effectRef>
-          <a:fontRef idx="minor">
-            <a:schemeClr val="lt1"/>
-          </a:fontRef>
-        </p:style>
-        <p:txBody>
-          <a:bodyPr rtlCol="0" anchor="ctr"/>
-          <a:lstStyle/>
-          <a:p>
-            <a:pPr algn="ctr"/>
-            <a:endParaRPr lang="en-GB"/>
-          </a:p>
-        </p:txBody>
-      </p:sp>
       <p:grpSp>
         <p:nvGrpSpPr>
           <p:cNvPr id="31" name="Group 30">

</xml_diff>